<commit_message>
refactor(scripts): drive doc generation with {{token}} placeholders
Replace positional/shape-name slot location in the docx and pptx
generators with token-based placeholder replacement. Templates carry
literal {{TOKEN}} markers; generators duplicate the branded template and
fill slots by token text, so the templates can be re-laid-out without
breaking generation.

- add token_fill.py shared engine (run-level substitution, spec loader)
- add tokenize_templates.py to inject markers into branded templates
- rewrite generate_docx/ppt to clone token-marked blocks by token
- route generate_xlsx through the shared loader (stays table-driven)
- delete dead dash-variant duplicates and stale create_templates.py

Co-Authored-By: Claude Opus 4.8 <noreply@anthropic.com>
</commit_message>
<xml_diff>
--- a/templates/Modele_AGEVP_Presentation.pptx
+++ b/templates/Modele_AGEVP_Presentation.pptx
@@ -1430,6 +1430,10 @@
           </a:solidFill>
           <a:ln/>
         </p:spPr>
+        <p:txBody>
+          <a:bodyPr/>
+          <a:p/>
+        </p:txBody>
       </p:sp>
       <p:sp>
         <p:nvSpPr>
@@ -1452,6 +1456,10 @@
           </a:solidFill>
           <a:ln/>
         </p:spPr>
+        <p:txBody>
+          <a:bodyPr/>
+          <a:p/>
+        </p:txBody>
       </p:sp>
       <p:sp>
         <p:nvSpPr>
@@ -1525,7 +1533,7 @@
                 <a:ea typeface="Cambria" pitchFamily="34" charset="-122"/>
                 <a:cs typeface="Cambria" pitchFamily="34" charset="-120"/>
               </a:rPr>
-              <a:t>[ Titre de la présentation ]</a:t>
+              <a:t>{{PRES_TITLE}}</a:t>
             </a:r>
             <a:endParaRPr lang="en-US" sz="4600" dirty="0"/>
           </a:p>
@@ -1564,7 +1572,7 @@
                 <a:ea typeface="Arial" pitchFamily="34" charset="-122"/>
                 <a:cs typeface="Arial" pitchFamily="34" charset="-120"/>
               </a:rPr>
-              <a:t>[ Sous-titre — ex. Soirée de rentrée 2026 ]</a:t>
+              <a:t>{{PRES_SUBTITLE}}</a:t>
             </a:r>
             <a:endParaRPr lang="en-US" sz="2000" dirty="0"/>
           </a:p>
@@ -1592,6 +1600,10 @@
             <a:prstDash val="solid"/>
           </a:ln>
         </p:spPr>
+        <p:txBody>
+          <a:bodyPr/>
+          <a:p/>
+        </p:txBody>
       </p:sp>
       <p:sp>
         <p:nvSpPr>
@@ -1626,7 +1638,7 @@
                 <a:ea typeface="Arial" pitchFamily="34" charset="-122"/>
                 <a:cs typeface="Arial" pitchFamily="34" charset="-120"/>
               </a:rPr>
-              <a:t>[ Date ]</a:t>
+              <a:t>{{PRES_DATE}}</a:t>
             </a:r>
             <a:pPr indent="0" marL="0">
               <a:buNone/>
@@ -1899,7 +1911,7 @@
                 <a:ea typeface="Cambria" pitchFamily="34" charset="-122"/>
                 <a:cs typeface="Cambria" pitchFamily="34" charset="-120"/>
               </a:rPr>
-              <a:t>[ Titre de la diapositive ]</a:t>
+              <a:t>{{SLIDE_TITLE}}</a:t>
             </a:r>
             <a:endParaRPr lang="en-US" sz="3200" dirty="0"/>
           </a:p>
@@ -1933,6 +1945,10 @@
             </a:outerShdw>
           </a:effectLst>
         </p:spPr>
+        <p:txBody>
+          <a:bodyPr/>
+          <a:p/>
+        </p:txBody>
       </p:sp>
       <p:sp>
         <p:nvSpPr>
@@ -1953,6 +1969,10 @@
           </a:solidFill>
           <a:ln/>
         </p:spPr>
+        <p:txBody>
+          <a:bodyPr/>
+          <a:p/>
+        </p:txBody>
       </p:sp>
       <p:pic>
         <p:nvPicPr>
@@ -2011,7 +2031,7 @@
                 <a:ea typeface="Arial" pitchFamily="34" charset="-122"/>
                 <a:cs typeface="Arial" pitchFamily="34" charset="-120"/>
               </a:rPr>
-              <a:t>[ Point clé 1 ]</a:t>
+              <a:t>{{POINT1}}</a:t>
             </a:r>
             <a:endParaRPr lang="en-US" sz="1800" dirty="0"/>
           </a:p>
@@ -2050,7 +2070,7 @@
                 <a:ea typeface="Arial" pitchFamily="34" charset="-122"/>
                 <a:cs typeface="Arial" pitchFamily="34" charset="-120"/>
               </a:rPr>
-              <a:t>[ Description courte du point. Remplacez ce texte par votre contenu. ]</a:t>
+              <a:t>{{POINT1_DESC}}</a:t>
             </a:r>
             <a:endParaRPr lang="en-US" sz="1400" dirty="0"/>
           </a:p>
@@ -2084,6 +2104,10 @@
             </a:outerShdw>
           </a:effectLst>
         </p:spPr>
+        <p:txBody>
+          <a:bodyPr/>
+          <a:p/>
+        </p:txBody>
       </p:sp>
       <p:sp>
         <p:nvSpPr>
@@ -2104,6 +2128,10 @@
           </a:solidFill>
           <a:ln/>
         </p:spPr>
+        <p:txBody>
+          <a:bodyPr/>
+          <a:p/>
+        </p:txBody>
       </p:sp>
       <p:pic>
         <p:nvPicPr>
@@ -2162,7 +2190,7 @@
                 <a:ea typeface="Arial" pitchFamily="34" charset="-122"/>
                 <a:cs typeface="Arial" pitchFamily="34" charset="-120"/>
               </a:rPr>
-              <a:t>[ Point clé 2 ]</a:t>
+              <a:t>{{POINT2}}</a:t>
             </a:r>
             <a:endParaRPr lang="en-US" sz="1800" dirty="0"/>
           </a:p>
@@ -2201,7 +2229,7 @@
                 <a:ea typeface="Arial" pitchFamily="34" charset="-122"/>
                 <a:cs typeface="Arial" pitchFamily="34" charset="-120"/>
               </a:rPr>
-              <a:t>[ Description courte du point. Remplacez ce texte par votre contenu. ]</a:t>
+              <a:t>{{POINT2_DESC}}</a:t>
             </a:r>
             <a:endParaRPr lang="en-US" sz="1400" dirty="0"/>
           </a:p>
@@ -2235,6 +2263,10 @@
             </a:outerShdw>
           </a:effectLst>
         </p:spPr>
+        <p:txBody>
+          <a:bodyPr/>
+          <a:p/>
+        </p:txBody>
       </p:sp>
       <p:sp>
         <p:nvSpPr>
@@ -2255,6 +2287,10 @@
           </a:solidFill>
           <a:ln/>
         </p:spPr>
+        <p:txBody>
+          <a:bodyPr/>
+          <a:p/>
+        </p:txBody>
       </p:sp>
       <p:pic>
         <p:nvPicPr>
@@ -2313,7 +2349,7 @@
                 <a:ea typeface="Arial" pitchFamily="34" charset="-122"/>
                 <a:cs typeface="Arial" pitchFamily="34" charset="-120"/>
               </a:rPr>
-              <a:t>[ Point clé 3 ]</a:t>
+              <a:t>{{POINT3}}</a:t>
             </a:r>
             <a:endParaRPr lang="en-US" sz="1800" dirty="0"/>
           </a:p>
@@ -2352,7 +2388,7 @@
                 <a:ea typeface="Arial" pitchFamily="34" charset="-122"/>
                 <a:cs typeface="Arial" pitchFamily="34" charset="-120"/>
               </a:rPr>
-              <a:t>[ Description courte du point. Remplacez ce texte par votre contenu. ]</a:t>
+              <a:t>{{POINT3_DESC}}</a:t>
             </a:r>
             <a:endParaRPr lang="en-US" sz="1400" dirty="0"/>
           </a:p>
@@ -2621,6 +2657,10 @@
             </a:outerShdw>
           </a:effectLst>
         </p:spPr>
+        <p:txBody>
+          <a:bodyPr/>
+          <a:p/>
+        </p:txBody>
       </p:sp>
       <p:sp>
         <p:nvSpPr>
@@ -2728,6 +2768,10 @@
             </a:outerShdw>
           </a:effectLst>
         </p:spPr>
+        <p:txBody>
+          <a:bodyPr/>
+          <a:p/>
+        </p:txBody>
       </p:sp>
       <p:sp>
         <p:nvSpPr>
@@ -2835,6 +2879,10 @@
             </a:outerShdw>
           </a:effectLst>
         </p:spPr>
+        <p:txBody>
+          <a:bodyPr/>
+          <a:p/>
+        </p:txBody>
       </p:sp>
       <p:sp>
         <p:nvSpPr>
@@ -2942,6 +2990,10 @@
             </a:outerShdw>
           </a:effectLst>
         </p:spPr>
+        <p:txBody>
+          <a:bodyPr/>
+          <a:p/>
+        </p:txBody>
       </p:sp>
       <p:sp>
         <p:nvSpPr>
@@ -4888,6 +4940,10 @@
             <a:prstDash val="solid"/>
           </a:ln>
         </p:spPr>
+        <p:txBody>
+          <a:bodyPr/>
+          <a:p/>
+        </p:txBody>
       </p:sp>
       <p:sp>
         <p:nvSpPr>
@@ -4915,6 +4971,10 @@
             </a:outerShdw>
           </a:effectLst>
         </p:spPr>
+        <p:txBody>
+          <a:bodyPr/>
+          <a:p/>
+        </p:txBody>
       </p:sp>
       <p:sp>
         <p:nvSpPr>
@@ -5098,6 +5158,10 @@
             </a:outerShdw>
           </a:effectLst>
         </p:spPr>
+        <p:txBody>
+          <a:bodyPr/>
+          <a:p/>
+        </p:txBody>
       </p:sp>
       <p:sp>
         <p:nvSpPr>
@@ -5281,6 +5345,10 @@
             </a:outerShdw>
           </a:effectLst>
         </p:spPr>
+        <p:txBody>
+          <a:bodyPr/>
+          <a:p/>
+        </p:txBody>
       </p:sp>
       <p:sp>
         <p:nvSpPr>
@@ -5464,6 +5532,10 @@
             </a:outerShdw>
           </a:effectLst>
         </p:spPr>
+        <p:txBody>
+          <a:bodyPr/>
+          <a:p/>
+        </p:txBody>
       </p:sp>
       <p:sp>
         <p:nvSpPr>
@@ -5674,6 +5746,10 @@
           </a:solidFill>
           <a:ln/>
         </p:spPr>
+        <p:txBody>
+          <a:bodyPr/>
+          <a:p/>
+        </p:txBody>
       </p:sp>
       <p:sp>
         <p:nvSpPr>
@@ -5775,6 +5851,10 @@
             <a:prstDash val="solid"/>
           </a:ln>
         </p:spPr>
+        <p:txBody>
+          <a:bodyPr/>
+          <a:p/>
+        </p:txBody>
       </p:sp>
       <p:sp>
         <p:nvSpPr>
@@ -5795,6 +5875,10 @@
           </a:solidFill>
           <a:ln/>
         </p:spPr>
+        <p:txBody>
+          <a:bodyPr/>
+          <a:p/>
+        </p:txBody>
       </p:sp>
       <p:pic>
         <p:nvPicPr>
@@ -5878,6 +5962,10 @@
           </a:solidFill>
           <a:ln/>
         </p:spPr>
+        <p:txBody>
+          <a:bodyPr/>
+          <a:p/>
+        </p:txBody>
       </p:sp>
       <p:pic>
         <p:nvPicPr>

</xml_diff>